<commit_message>
debug claude code pass#13
</commit_message>
<xml_diff>
--- a/tests/tmp/merge_no_dup.pptx
+++ b/tests/tmp/merge_no_dup.pptx
@@ -109,15 +109,6 @@
     </a:lvl9pPr>
   </p:defaultTextStyle>
   <p:extLst>
-    <p:ext uri="{521415D9-36F7-43E2-AB2F-B90AF26B5E84}">
-      <p14:sectionLst xmlns:p14="http://schemas.microsoft.com/office/powerpoint/2010/main">
-        <p14:section name="FIN" id="{F9BB27DB-5C58-47A1-A1B8-D46C8599990A}">
-          <p14:sldIdLst>
-            <p14:sldId id="256"/>
-          </p14:sldIdLst>
-        </p14:section>
-      </p14:sectionLst>
-    </p:ext>
     <p:ext uri="{EFAFB233-063F-42B5-8137-9DF3F51BA10A}">
       <p15:sldGuideLst xmlns:p15="http://schemas.microsoft.com/office/powerpoint/2012/main">
         <p15:guide id="1" orient="horz" pos="2268" userDrawn="1">
@@ -156,6 +147,16 @@
           </p15:clr>
         </p15:guide>
       </p15:sldGuideLst>
+    </p:ext>
+    <p:ext uri="{521415D9-36F7-43E2-AB2F-B90AF26B5E84}">
+      <p14:sectionLst xmlns:p14="http://schemas.microsoft.com/office/powerpoint/2010/main">
+        <p14:section name="FIN" id="{F9BB27DB-5C58-47A1-A1B8-D46C8599990A}">
+          <p14:sldIdLst>
+            <p14:sldId id="256"/>
+            <p14:sldId id="257"/>
+          </p14:sldIdLst>
+        </p14:section>
+      </p14:sectionLst>
     </p:ext>
   </p:extLst>
 </p:presentation>

</xml_diff>

<commit_message>
debug claude code pass#14
</commit_message>
<xml_diff>
--- a/tests/tmp/merge_no_dup.pptx
+++ b/tests/tmp/merge_no_dup.pptx
@@ -2,7 +2,7 @@
 <file path=ppt/presentation.xml><?xml version="1.0" encoding="utf-8"?>
 <p:presentation xmlns:a="http://schemas.openxmlformats.org/drawingml/2006/main" xmlns:r="http://schemas.openxmlformats.org/officeDocument/2006/relationships" xmlns:p="http://schemas.openxmlformats.org/presentationml/2006/main" saveSubsetFonts="1">
   <p:sldMasterIdLst>
-    <p:sldMasterId id="2147483786" r:id="rId1"/>
+    <p:sldMasterId id="2147483773" r:id="rId1"/>
   </p:sldMasterIdLst>
   <p:notesMasterIdLst>
     <p:notesMasterId r:id="rId3"/>
@@ -3226,17 +3226,17 @@
   </p:cSld>
   <p:clrMap bg1="lt1" tx1="dk1" bg2="lt2" tx2="dk2" accent1="accent1" accent2="accent2" accent3="accent3" accent4="accent4" accent5="accent5" accent6="accent6" hlink="hlink" folHlink="folHlink"/>
   <p:sldLayoutIdLst>
-    <p:sldLayoutId id="2147483774" r:id="rId1"/>
-    <p:sldLayoutId id="2147483775" r:id="rId2"/>
-    <p:sldLayoutId id="2147483776" r:id="rId3"/>
-    <p:sldLayoutId id="2147483777" r:id="rId4"/>
-    <p:sldLayoutId id="2147483778" r:id="rId5"/>
-    <p:sldLayoutId id="2147483779" r:id="rId6"/>
-    <p:sldLayoutId id="2147483780" r:id="rId7"/>
-    <p:sldLayoutId id="2147483781" r:id="rId8"/>
-    <p:sldLayoutId id="2147483782" r:id="rId9"/>
-    <p:sldLayoutId id="2147483783" r:id="rId10"/>
-    <p:sldLayoutId id="2147483784" r:id="rId11"/>
+    <p:sldLayoutId id="2147483761" r:id="rId1"/>
+    <p:sldLayoutId id="2147483762" r:id="rId2"/>
+    <p:sldLayoutId id="2147483763" r:id="rId3"/>
+    <p:sldLayoutId id="2147483764" r:id="rId4"/>
+    <p:sldLayoutId id="2147483765" r:id="rId5"/>
+    <p:sldLayoutId id="2147483766" r:id="rId6"/>
+    <p:sldLayoutId id="2147483767" r:id="rId7"/>
+    <p:sldLayoutId id="2147483768" r:id="rId8"/>
+    <p:sldLayoutId id="2147483769" r:id="rId9"/>
+    <p:sldLayoutId id="2147483770" r:id="rId10"/>
+    <p:sldLayoutId id="2147483771" r:id="rId11"/>
   </p:sldLayoutIdLst>
   <p:txStyles>
     <p:titleStyle>

</xml_diff>